<commit_message>
folien: untertitel angeglichen, montags-ansage auf der schlussfolie abgesichert
</commit_message>
<xml_diff>
--- a/folien/dist/01-netzwerke-grundlagen.pptx
+++ b/folien/dist/01-netzwerke-grundlagen.pptx
@@ -3433,7 +3433,7 @@
                 <a:ea typeface="Arial" pitchFamily="34" charset="-122"/>
                 <a:cs typeface="Arial" pitchFamily="34" charset="-120"/>
               </a:rPr>
-              <a:t>Auffrischung auf gemeinsamen Stand – und der Blick auf das, was in der Ausbildung fehlte</a:t>
+              <a:t>Auffrischung auf gemeinsamen Stand – und der Blick auf das, was in der Ausbildung nicht vorkam</a:t>
             </a:r>
             <a:endParaRPr lang="en-US" sz="1700" dirty="0"/>
           </a:p>
@@ -3704,7 +3704,7 @@
                 <a:ea typeface="Arial" pitchFamily="34" charset="-122"/>
                 <a:cs typeface="Arial" pitchFamily="34" charset="-120"/>
               </a:rPr>
-              <a:t>Die Begriffe, bei denen es erfahrungsgemäß auseinandergeht</a:t>
+              <a:t>Die Begriffe, bei denen es gern auseinandergeht</a:t>
             </a:r>
             <a:endParaRPr lang="en-US" sz="1350" dirty="0"/>
           </a:p>
@@ -14477,7 +14477,7 @@
                 <a:ea typeface="Arial" pitchFamily="34" charset="-122"/>
                 <a:cs typeface="Arial" pitchFamily="34" charset="-120"/>
               </a:rPr>
-              <a:t>Montag, 31. August · Adressierung und Subnetting</a:t>
+              <a:t>Montag, 31. August · Adressierung und Subnetting · Papier und Stift mitbringen</a:t>
             </a:r>
             <a:endParaRPr lang="en-US" sz="1600" dirty="0"/>
           </a:p>

</xml_diff>

<commit_message>
folien: standortbestimmung auf der bis-montag-folie
</commit_message>
<xml_diff>
--- a/folien/dist/01-netzwerke-grundlagen.pptx
+++ b/folien/dist/01-netzwerke-grundlagen.pptx
@@ -13785,7 +13785,7 @@
                 <a:ea typeface="Arial" pitchFamily="34" charset="-122"/>
                 <a:cs typeface="Arial" pitchFamily="34" charset="-120"/>
               </a:rPr>
-              <a:t>Alles freiwillig – aber der Montag wird deutlich leichter, wenn ihr das gemacht habt.</a:t>
+              <a:t>Eine Bitte und drei Angebote – die Bitte zuerst.</a:t>
             </a:r>
             <a:endParaRPr lang="en-US" sz="1300" dirty="0"/>
           </a:p>
@@ -13800,7 +13800,7 @@
         <p:spPr>
           <a:xfrm>
             <a:off x="566928" y="1975104"/>
-            <a:ext cx="2523744" cy="1920240"/>
+            <a:ext cx="1879092" cy="1920240"/>
           </a:xfrm>
           <a:prstGeom prst="rect">
             <a:avLst/>
@@ -13826,7 +13826,7 @@
             <a:avLst/>
           </a:prstGeom>
           <a:solidFill>
-            <a:srgbClr val="3843AF"/>
+            <a:srgbClr val="9A6310"/>
           </a:solidFill>
           <a:ln/>
         </p:spPr>
@@ -13840,7 +13840,7 @@
         <p:spPr>
           <a:xfrm>
             <a:off x="804672" y="2121408"/>
-            <a:ext cx="2121408" cy="256032"/>
+            <a:ext cx="1476756" cy="384048"/>
           </a:xfrm>
           <a:prstGeom prst="rect">
             <a:avLst/>
@@ -13856,7 +13856,7 @@
               <a:buNone/>
             </a:pPr>
             <a:r>
-              <a:rPr lang="en-US" sz="1300" b="1" dirty="0">
+              <a:rPr lang="en-US" sz="1200" b="1" dirty="0">
                 <a:solidFill>
                   <a:srgbClr val="272E52"/>
                 </a:solidFill>
@@ -13864,9 +13864,9 @@
                 <a:ea typeface="Arial" pitchFamily="34" charset="-122"/>
                 <a:cs typeface="Arial" pitchFamily="34" charset="-120"/>
               </a:rPr>
-              <a:t>Nur wenn etwas hakte</a:t>
-            </a:r>
-            <a:endParaRPr lang="en-US" sz="1300" dirty="0"/>
+              <a:t>Standortbestimmung</a:t>
+            </a:r>
+            <a:endParaRPr lang="en-US" sz="1200" dirty="0"/>
           </a:p>
         </p:txBody>
       </p:sp>
@@ -13878,8 +13878,8 @@
         </p:nvSpPr>
         <p:spPr>
           <a:xfrm>
-            <a:off x="804672" y="2423160"/>
-            <a:ext cx="2121408" cy="1353312"/>
+            <a:off x="804672" y="2551176"/>
+            <a:ext cx="1476756" cy="1225296"/>
           </a:xfrm>
           <a:prstGeom prst="rect">
             <a:avLst/>
@@ -13898,7 +13898,7 @@
               <a:buNone/>
             </a:pPr>
             <a:r>
-              <a:rPr lang="en-US" sz="1150" dirty="0">
+              <a:rPr lang="en-US" sz="1050" dirty="0">
                 <a:solidFill>
                   <a:srgbClr val="434A63"/>
                 </a:solidFill>
@@ -13906,9 +13906,9 @@
                 <a:ea typeface="Arial" pitchFamily="34" charset="-122"/>
                 <a:cs typeface="Arial" pitchFamily="34" charset="-120"/>
               </a:rPr>
-              <a:t>Die Seiten „Grundbegriffe“ und „OSI- und TCP/IP-Modell“ stehen auf der Kursseite. Gedacht für die Stellen, an denen ihr heute gestockt habt – nicht zum Durchlesen.</a:t>
-            </a:r>
-            <a:endParaRPr lang="en-US" sz="1150" dirty="0"/>
+              <a:t>Das Formular aus dem Chat: gut 20 Minuten, bis Montag. Kein Test – es zeigt mir, wo wir gründlich einsteigen müssen.</a:t>
+            </a:r>
+            <a:endParaRPr lang="en-US" sz="1050" dirty="0"/>
           </a:p>
         </p:txBody>
       </p:sp>
@@ -13920,8 +13920,8 @@
         </p:nvSpPr>
         <p:spPr>
           <a:xfrm>
-            <a:off x="3310128" y="1975104"/>
-            <a:ext cx="2523744" cy="1920240"/>
+            <a:off x="2610612" y="1975104"/>
+            <a:ext cx="1879092" cy="1920240"/>
           </a:xfrm>
           <a:prstGeom prst="rect">
             <a:avLst/>
@@ -13940,7 +13940,7 @@
         </p:nvSpPr>
         <p:spPr>
           <a:xfrm>
-            <a:off x="3310128" y="1975104"/>
+            <a:off x="2610612" y="1975104"/>
             <a:ext cx="41148" cy="1920240"/>
           </a:xfrm>
           <a:prstGeom prst="rect">
@@ -13960,8 +13960,8 @@
         </p:nvSpPr>
         <p:spPr>
           <a:xfrm>
-            <a:off x="3547872" y="2121408"/>
-            <a:ext cx="2121408" cy="256032"/>
+            <a:off x="2848356" y="2121408"/>
+            <a:ext cx="1476756" cy="384048"/>
           </a:xfrm>
           <a:prstGeom prst="rect">
             <a:avLst/>
@@ -13977,7 +13977,7 @@
               <a:buNone/>
             </a:pPr>
             <a:r>
-              <a:rPr lang="en-US" sz="1300" b="1" dirty="0">
+              <a:rPr lang="en-US" sz="1200" b="1" dirty="0">
                 <a:solidFill>
                   <a:srgbClr val="272E52"/>
                 </a:solidFill>
@@ -13985,9 +13985,9 @@
                 <a:ea typeface="Arial" pitchFamily="34" charset="-122"/>
                 <a:cs typeface="Arial" pitchFamily="34" charset="-120"/>
               </a:rPr>
-              <a:t>Nachholen</a:t>
-            </a:r>
-            <a:endParaRPr lang="en-US" sz="1300" dirty="0"/>
+              <a:t>Nur wenn etwas hakte</a:t>
+            </a:r>
+            <a:endParaRPr lang="en-US" sz="1200" dirty="0"/>
           </a:p>
         </p:txBody>
       </p:sp>
@@ -13999,8 +13999,8 @@
         </p:nvSpPr>
         <p:spPr>
           <a:xfrm>
-            <a:off x="3547872" y="2423160"/>
-            <a:ext cx="2121408" cy="1353312"/>
+            <a:off x="2848356" y="2551176"/>
+            <a:ext cx="1476756" cy="1225296"/>
           </a:xfrm>
           <a:prstGeom prst="rect">
             <a:avLst/>
@@ -14019,7 +14019,7 @@
               <a:buNone/>
             </a:pPr>
             <a:r>
-              <a:rPr lang="en-US" sz="1150" dirty="0">
+              <a:rPr lang="en-US" sz="1050" dirty="0">
                 <a:solidFill>
                   <a:srgbClr val="434A63"/>
                 </a:solidFill>
@@ -14027,9 +14027,9 @@
                 <a:ea typeface="Arial" pitchFamily="34" charset="-122"/>
                 <a:cs typeface="Arial" pitchFamily="34" charset="-120"/>
               </a:rPr>
-              <a:t>Wer nicht bis zu den Störungen gekommen ist: Station 3 lohnt sich. Die Auflösungen stehen zum Aufklappen darunter.</a:t>
-            </a:r>
-            <a:endParaRPr lang="en-US" sz="1150" dirty="0"/>
+              <a:t>„Grundbegriffe“ und „OSI- und TCP/IP-Modell“ stehen auf der Kursseite – für die Stellen, an denen ihr heute gestockt habt.</a:t>
+            </a:r>
+            <a:endParaRPr lang="en-US" sz="1050" dirty="0"/>
           </a:p>
         </p:txBody>
       </p:sp>
@@ -14041,8 +14041,8 @@
         </p:nvSpPr>
         <p:spPr>
           <a:xfrm>
-            <a:off x="6053328" y="1975104"/>
-            <a:ext cx="2523744" cy="1920240"/>
+            <a:off x="4654296" y="1975104"/>
+            <a:ext cx="1879092" cy="1920240"/>
           </a:xfrm>
           <a:prstGeom prst="rect">
             <a:avLst/>
@@ -14061,7 +14061,7 @@
         </p:nvSpPr>
         <p:spPr>
           <a:xfrm>
-            <a:off x="6053328" y="1975104"/>
+            <a:off x="4654296" y="1975104"/>
             <a:ext cx="41148" cy="1920240"/>
           </a:xfrm>
           <a:prstGeom prst="rect">
@@ -14081,8 +14081,8 @@
         </p:nvSpPr>
         <p:spPr>
           <a:xfrm>
-            <a:off x="6291072" y="2121408"/>
-            <a:ext cx="2121408" cy="256032"/>
+            <a:off x="4892040" y="2121408"/>
+            <a:ext cx="1476756" cy="384048"/>
           </a:xfrm>
           <a:prstGeom prst="rect">
             <a:avLst/>
@@ -14098,7 +14098,7 @@
               <a:buNone/>
             </a:pPr>
             <a:r>
-              <a:rPr lang="en-US" sz="1300" b="1" dirty="0">
+              <a:rPr lang="en-US" sz="1200" b="1" dirty="0">
                 <a:solidFill>
                   <a:srgbClr val="272E52"/>
                 </a:solidFill>
@@ -14106,9 +14106,9 @@
                 <a:ea typeface="Arial" pitchFamily="34" charset="-122"/>
                 <a:cs typeface="Arial" pitchFamily="34" charset="-120"/>
               </a:rPr>
-              <a:t>Vorbereiten</a:t>
-            </a:r>
-            <a:endParaRPr lang="en-US" sz="1300" dirty="0"/>
+              <a:t>Nachholen</a:t>
+            </a:r>
+            <a:endParaRPr lang="en-US" sz="1200" dirty="0"/>
           </a:p>
         </p:txBody>
       </p:sp>
@@ -14120,8 +14120,8 @@
         </p:nvSpPr>
         <p:spPr>
           <a:xfrm>
-            <a:off x="6291072" y="2423160"/>
-            <a:ext cx="2121408" cy="1353312"/>
+            <a:off x="4892040" y="2551176"/>
+            <a:ext cx="1476756" cy="1225296"/>
           </a:xfrm>
           <a:prstGeom prst="rect">
             <a:avLst/>
@@ -14140,7 +14140,7 @@
               <a:buNone/>
             </a:pPr>
             <a:r>
-              <a:rPr lang="en-US" sz="1150" dirty="0">
+              <a:rPr lang="en-US" sz="1050" dirty="0">
                 <a:solidFill>
                   <a:srgbClr val="434A63"/>
                 </a:solidFill>
@@ -14148,9 +14148,9 @@
                 <a:ea typeface="Arial" pitchFamily="34" charset="-122"/>
                 <a:cs typeface="Arial" pitchFamily="34" charset="-120"/>
               </a:rPr>
-              <a:t>Am Montag rechnen wir Subnetze. Bringt Papier, Stift und einen wachen Kopf mit – Taschenrechner braucht ihr nicht.</a:t>
-            </a:r>
-            <a:endParaRPr lang="en-US" sz="1150" dirty="0"/>
+              <a:t>Wer nicht bis zu den Störungen kam: Station 3 lohnt sich. Die Auflösungen stehen zum Aufklappen darunter.</a:t>
+            </a:r>
+            <a:endParaRPr lang="en-US" sz="1050" dirty="0"/>
           </a:p>
         </p:txBody>
       </p:sp>
@@ -14162,8 +14162,28 @@
         </p:nvSpPr>
         <p:spPr>
           <a:xfrm>
-            <a:off x="566928" y="4160520"/>
-            <a:ext cx="32004" cy="256032"/>
+            <a:off x="6697980" y="1975104"/>
+            <a:ext cx="1879092" cy="1920240"/>
+          </a:xfrm>
+          <a:prstGeom prst="rect">
+            <a:avLst/>
+          </a:prstGeom>
+          <a:solidFill>
+            <a:srgbClr val="F5F6FC"/>
+          </a:solidFill>
+          <a:ln/>
+        </p:spPr>
+      </p:sp>
+      <p:sp>
+        <p:nvSpPr>
+          <p:cNvPr id="19" name="Shape 17"/>
+          <p:cNvSpPr/>
+          <p:nvPr/>
+        </p:nvSpPr>
+        <p:spPr>
+          <a:xfrm>
+            <a:off x="6697980" y="1975104"/>
+            <a:ext cx="41148" cy="1920240"/>
           </a:xfrm>
           <a:prstGeom prst="rect">
             <a:avLst/>
@@ -14176,7 +14196,108 @@
       </p:sp>
       <p:sp>
         <p:nvSpPr>
-          <p:cNvPr id="19" name="Text 17"/>
+          <p:cNvPr id="20" name="Text 18"/>
+          <p:cNvSpPr/>
+          <p:nvPr/>
+        </p:nvSpPr>
+        <p:spPr>
+          <a:xfrm>
+            <a:off x="6935724" y="2121408"/>
+            <a:ext cx="1476756" cy="384048"/>
+          </a:xfrm>
+          <a:prstGeom prst="rect">
+            <a:avLst/>
+          </a:prstGeom>
+          <a:noFill/>
+          <a:ln/>
+        </p:spPr>
+        <p:txBody>
+          <a:bodyPr wrap="square" lIns="0" tIns="0" rIns="0" bIns="0" rtlCol="0" anchor="t"/>
+          <a:lstStyle/>
+          <a:p>
+            <a:pPr indent="0" marL="0">
+              <a:buNone/>
+            </a:pPr>
+            <a:r>
+              <a:rPr lang="en-US" sz="1200" b="1" dirty="0">
+                <a:solidFill>
+                  <a:srgbClr val="272E52"/>
+                </a:solidFill>
+                <a:latin typeface="Arial" pitchFamily="34" charset="0"/>
+                <a:ea typeface="Arial" pitchFamily="34" charset="-122"/>
+                <a:cs typeface="Arial" pitchFamily="34" charset="-120"/>
+              </a:rPr>
+              <a:t>Vorbereiten</a:t>
+            </a:r>
+            <a:endParaRPr lang="en-US" sz="1200" dirty="0"/>
+          </a:p>
+        </p:txBody>
+      </p:sp>
+      <p:sp>
+        <p:nvSpPr>
+          <p:cNvPr id="21" name="Text 19"/>
+          <p:cNvSpPr/>
+          <p:nvPr/>
+        </p:nvSpPr>
+        <p:spPr>
+          <a:xfrm>
+            <a:off x="6935724" y="2551176"/>
+            <a:ext cx="1476756" cy="1225296"/>
+          </a:xfrm>
+          <a:prstGeom prst="rect">
+            <a:avLst/>
+          </a:prstGeom>
+          <a:noFill/>
+          <a:ln/>
+        </p:spPr>
+        <p:txBody>
+          <a:bodyPr wrap="square" lIns="0" tIns="0" rIns="0" bIns="0" rtlCol="0" anchor="t"/>
+          <a:lstStyle/>
+          <a:p>
+            <a:pPr indent="0" marL="0">
+              <a:lnSpc>
+                <a:spcPct val="92000"/>
+              </a:lnSpc>
+              <a:buNone/>
+            </a:pPr>
+            <a:r>
+              <a:rPr lang="en-US" sz="1050" dirty="0">
+                <a:solidFill>
+                  <a:srgbClr val="434A63"/>
+                </a:solidFill>
+                <a:latin typeface="Arial" pitchFamily="34" charset="0"/>
+                <a:ea typeface="Arial" pitchFamily="34" charset="-122"/>
+                <a:cs typeface="Arial" pitchFamily="34" charset="-120"/>
+              </a:rPr>
+              <a:t>Montag rechnen wir Subnetze. Papier und Stift reichen – Taschenrechner braucht ihr nicht.</a:t>
+            </a:r>
+            <a:endParaRPr lang="en-US" sz="1050" dirty="0"/>
+          </a:p>
+        </p:txBody>
+      </p:sp>
+      <p:sp>
+        <p:nvSpPr>
+          <p:cNvPr id="22" name="Shape 20"/>
+          <p:cNvSpPr/>
+          <p:nvPr/>
+        </p:nvSpPr>
+        <p:spPr>
+          <a:xfrm>
+            <a:off x="566928" y="4160520"/>
+            <a:ext cx="32004" cy="256032"/>
+          </a:xfrm>
+          <a:prstGeom prst="rect">
+            <a:avLst/>
+          </a:prstGeom>
+          <a:solidFill>
+            <a:srgbClr val="3843AF"/>
+          </a:solidFill>
+          <a:ln/>
+        </p:spPr>
+      </p:sp>
+      <p:sp>
+        <p:nvSpPr>
+          <p:cNvPr id="23" name="Text 21"/>
           <p:cNvSpPr/>
           <p:nvPr/>
         </p:nvSpPr>
@@ -14215,7 +14336,7 @@
       </p:sp>
       <p:sp>
         <p:nvSpPr>
-          <p:cNvPr id="20" name="Shape 18"/>
+          <p:cNvPr id="24" name="Shape 22"/>
           <p:cNvSpPr/>
           <p:nvPr/>
         </p:nvSpPr>
@@ -14238,7 +14359,7 @@
       </p:sp>
       <p:sp>
         <p:nvSpPr>
-          <p:cNvPr id="21" name="Text 19"/>
+          <p:cNvPr id="25" name="Text 23"/>
           <p:cNvSpPr/>
           <p:nvPr/>
         </p:nvSpPr>
@@ -14277,7 +14398,7 @@
       </p:sp>
       <p:sp>
         <p:nvSpPr>
-          <p:cNvPr id="22" name="Text 20"/>
+          <p:cNvPr id="26" name="Text 24"/>
           <p:cNvSpPr/>
           <p:nvPr/>
         </p:nvSpPr>

</xml_diff>

<commit_message>
folien: redundante alltagsfall-karte entfernt, jitter und paketverlust ausformuliert
</commit_message>
<xml_diff>
--- a/folien/dist/01-netzwerke-grundlagen.pptx
+++ b/folien/dist/01-netzwerke-grundlagen.pptx
@@ -8073,7 +8073,7 @@
         <p:spPr>
           <a:xfrm>
             <a:off x="566928" y="3346704"/>
-            <a:ext cx="2523744" cy="1097280"/>
+            <a:ext cx="3895344" cy="1097280"/>
           </a:xfrm>
           <a:prstGeom prst="rect">
             <a:avLst/>
@@ -8113,7 +8113,7 @@
         <p:spPr>
           <a:xfrm>
             <a:off x="804672" y="3493008"/>
-            <a:ext cx="2121408" cy="242062"/>
+            <a:ext cx="3493008" cy="242062"/>
           </a:xfrm>
           <a:prstGeom prst="rect">
             <a:avLst/>
@@ -8152,7 +8152,7 @@
         <p:spPr>
           <a:xfrm>
             <a:off x="804672" y="3780790"/>
-            <a:ext cx="2121408" cy="544322"/>
+            <a:ext cx="3493008" cy="544322"/>
           </a:xfrm>
           <a:prstGeom prst="rect">
             <a:avLst/>
@@ -8179,7 +8179,7 @@
                 <a:ea typeface="Arial" pitchFamily="34" charset="-122"/>
                 <a:cs typeface="Arial" pitchFamily="34" charset="-120"/>
               </a:rPr>
-              <a:t>Schwankende Latenz. Stört Sprache und Video.</a:t>
+              <a:t>Schwankende Latenz. Stört Telefonie und Video – ein Download merkt davon nichts.</a:t>
             </a:r>
             <a:endParaRPr lang="en-US" sz="1100" dirty="0"/>
           </a:p>
@@ -8193,8 +8193,8 @@
         </p:nvSpPr>
         <p:spPr>
           <a:xfrm>
-            <a:off x="3310128" y="3346704"/>
-            <a:ext cx="2523744" cy="1097280"/>
+            <a:off x="4681728" y="3346704"/>
+            <a:ext cx="3895344" cy="1097280"/>
           </a:xfrm>
           <a:prstGeom prst="rect">
             <a:avLst/>
@@ -8213,7 +8213,7 @@
         </p:nvSpPr>
         <p:spPr>
           <a:xfrm>
-            <a:off x="3310128" y="3346704"/>
+            <a:off x="4681728" y="3346704"/>
             <a:ext cx="41148" cy="1097280"/>
           </a:xfrm>
           <a:prstGeom prst="rect">
@@ -8233,8 +8233,8 @@
         </p:nvSpPr>
         <p:spPr>
           <a:xfrm>
-            <a:off x="3547872" y="3493008"/>
-            <a:ext cx="2121408" cy="242062"/>
+            <a:off x="4919472" y="3493008"/>
+            <a:ext cx="3493008" cy="242062"/>
           </a:xfrm>
           <a:prstGeom prst="rect">
             <a:avLst/>
@@ -8272,8 +8272,8 @@
         </p:nvSpPr>
         <p:spPr>
           <a:xfrm>
-            <a:off x="3547872" y="3780790"/>
-            <a:ext cx="2121408" cy="544322"/>
+            <a:off x="4919472" y="3780790"/>
+            <a:ext cx="3493008" cy="544322"/>
           </a:xfrm>
           <a:prstGeom prst="rect">
             <a:avLst/>
@@ -8300,7 +8300,7 @@
                 <a:ea typeface="Arial" pitchFamily="34" charset="-122"/>
                 <a:cs typeface="Arial" pitchFamily="34" charset="-120"/>
               </a:rPr>
-              <a:t>Was unterwegs verloren geht. TCP holt es nach – das kostet Zeit.</a:t>
+              <a:t>Was unterwegs verloren geht. TCP schickt es nach – und das Nachschicken kostet die Zeit.</a:t>
             </a:r>
             <a:endParaRPr lang="en-US" sz="1100" dirty="0"/>
           </a:p>
@@ -8309,127 +8309,6 @@
       <p:sp>
         <p:nvSpPr>
           <p:cNvPr id="14" name="Shape 11"/>
-          <p:cNvSpPr/>
-          <p:nvPr/>
-        </p:nvSpPr>
-        <p:spPr>
-          <a:xfrm>
-            <a:off x="6053328" y="3346704"/>
-            <a:ext cx="2523744" cy="1097280"/>
-          </a:xfrm>
-          <a:prstGeom prst="rect">
-            <a:avLst/>
-          </a:prstGeom>
-          <a:solidFill>
-            <a:srgbClr val="F5F6FC"/>
-          </a:solidFill>
-          <a:ln/>
-        </p:spPr>
-      </p:sp>
-      <p:sp>
-        <p:nvSpPr>
-          <p:cNvPr id="15" name="Shape 12"/>
-          <p:cNvSpPr/>
-          <p:nvPr/>
-        </p:nvSpPr>
-        <p:spPr>
-          <a:xfrm>
-            <a:off x="6053328" y="3346704"/>
-            <a:ext cx="41148" cy="1097280"/>
-          </a:xfrm>
-          <a:prstGeom prst="rect">
-            <a:avLst/>
-          </a:prstGeom>
-          <a:solidFill>
-            <a:srgbClr val="3843AF"/>
-          </a:solidFill>
-          <a:ln/>
-        </p:spPr>
-      </p:sp>
-      <p:sp>
-        <p:nvSpPr>
-          <p:cNvPr id="16" name="Text 13"/>
-          <p:cNvSpPr/>
-          <p:nvPr/>
-        </p:nvSpPr>
-        <p:spPr>
-          <a:xfrm>
-            <a:off x="6291072" y="3493008"/>
-            <a:ext cx="2121408" cy="242062"/>
-          </a:xfrm>
-          <a:prstGeom prst="rect">
-            <a:avLst/>
-          </a:prstGeom>
-          <a:noFill/>
-          <a:ln/>
-        </p:spPr>
-        <p:txBody>
-          <a:bodyPr wrap="square" lIns="0" tIns="0" rIns="0" bIns="0" rtlCol="0" anchor="t"/>
-          <a:lstStyle/>
-          <a:p>
-            <a:pPr indent="0" marL="0">
-              <a:buNone/>
-            </a:pPr>
-            <a:r>
-              <a:rPr lang="en-US" sz="1300" b="1" dirty="0">
-                <a:solidFill>
-                  <a:srgbClr val="272E52"/>
-                </a:solidFill>
-                <a:latin typeface="Arial" pitchFamily="34" charset="0"/>
-                <a:ea typeface="Arial" pitchFamily="34" charset="-122"/>
-                <a:cs typeface="Arial" pitchFamily="34" charset="-120"/>
-              </a:rPr>
-              <a:t>Der Alltagsfall</a:t>
-            </a:r>
-            <a:endParaRPr lang="en-US" sz="1300" dirty="0"/>
-          </a:p>
-        </p:txBody>
-      </p:sp>
-      <p:sp>
-        <p:nvSpPr>
-          <p:cNvPr id="17" name="Text 14"/>
-          <p:cNvSpPr/>
-          <p:nvPr/>
-        </p:nvSpPr>
-        <p:spPr>
-          <a:xfrm>
-            <a:off x="6291072" y="3780790"/>
-            <a:ext cx="2121408" cy="544322"/>
-          </a:xfrm>
-          <a:prstGeom prst="rect">
-            <a:avLst/>
-          </a:prstGeom>
-          <a:noFill/>
-          <a:ln/>
-        </p:spPr>
-        <p:txBody>
-          <a:bodyPr wrap="square" lIns="0" tIns="0" rIns="0" bIns="0" rtlCol="0" anchor="t"/>
-          <a:lstStyle/>
-          <a:p>
-            <a:pPr indent="0" marL="0">
-              <a:lnSpc>
-                <a:spcPct val="92000"/>
-              </a:lnSpc>
-              <a:buNone/>
-            </a:pPr>
-            <a:r>
-              <a:rPr lang="en-US" sz="1100" dirty="0">
-                <a:solidFill>
-                  <a:srgbClr val="434A63"/>
-                </a:solidFill>
-                <a:latin typeface="Arial" pitchFamily="34" charset="0"/>
-                <a:ea typeface="Arial" pitchFamily="34" charset="-122"/>
-                <a:cs typeface="Arial" pitchFamily="34" charset="-120"/>
-              </a:rPr>
-              <a:t>„Die Leitung ist zu klein" stimmt selten. Meist wartet etwas anderes.</a:t>
-            </a:r>
-            <a:endParaRPr lang="en-US" sz="1100" dirty="0"/>
-          </a:p>
-        </p:txBody>
-      </p:sp>
-      <p:sp>
-        <p:nvSpPr>
-          <p:cNvPr id="18" name="Shape 15"/>
           <p:cNvSpPr/>
           <p:nvPr/>
         </p:nvSpPr>
@@ -8452,7 +8331,7 @@
       </p:sp>
       <p:sp>
         <p:nvSpPr>
-          <p:cNvPr id="19" name="Text 16"/>
+          <p:cNvPr id="15" name="Text 12"/>
           <p:cNvSpPr/>
           <p:nvPr/>
         </p:nvSpPr>
@@ -8491,7 +8370,7 @@
       </p:sp>
       <p:sp>
         <p:nvSpPr>
-          <p:cNvPr id="20" name="Text 17"/>
+          <p:cNvPr id="16" name="Text 13"/>
           <p:cNvSpPr/>
           <p:nvPr/>
         </p:nvSpPr>

</xml_diff>

<commit_message>
folien: kapselung als einpack-schritte mit http-benennung, osi-zeilen 5 und 6 klarer formuliert
</commit_message>
<xml_diff>
--- a/folien/dist/01-netzwerke-grundlagen.pptx
+++ b/folien/dist/01-netzwerke-grundlagen.pptx
@@ -10780,8 +10780,8 @@
         </p:blipFill>
         <p:spPr>
           <a:xfrm>
-            <a:off x="566928" y="1554480"/>
-            <a:ext cx="8010144" cy="1874520"/>
+            <a:off x="566928" y="1536192"/>
+            <a:ext cx="8010144" cy="2304288"/>
           </a:xfrm>
           <a:prstGeom prst="rect">
             <a:avLst/>
@@ -10796,28 +10796,8 @@
         </p:nvSpPr>
         <p:spPr>
           <a:xfrm>
-            <a:off x="566928" y="3584448"/>
-            <a:ext cx="8010144" cy="804672"/>
-          </a:xfrm>
-          <a:prstGeom prst="rect">
-            <a:avLst/>
-          </a:prstGeom>
-          <a:solidFill>
-            <a:srgbClr val="EEF0FB"/>
-          </a:solidFill>
-          <a:ln/>
-        </p:spPr>
-      </p:sp>
-      <p:sp>
-        <p:nvSpPr>
-          <p:cNvPr id="7" name="Shape 4"/>
-          <p:cNvSpPr/>
-          <p:nvPr/>
-        </p:nvSpPr>
-        <p:spPr>
-          <a:xfrm>
-            <a:off x="566928" y="3584448"/>
-            <a:ext cx="41148" cy="804672"/>
+            <a:off x="566928" y="4105656"/>
+            <a:ext cx="32004" cy="256032"/>
           </a:xfrm>
           <a:prstGeom prst="rect">
             <a:avLst/>
@@ -10830,33 +10810,30 @@
       </p:sp>
       <p:sp>
         <p:nvSpPr>
-          <p:cNvPr id="8" name="Text 5"/>
-          <p:cNvSpPr/>
-          <p:nvPr/>
-        </p:nvSpPr>
-        <p:spPr>
-          <a:xfrm>
-            <a:off x="804672" y="3730752"/>
-            <a:ext cx="7607808" cy="539496"/>
-          </a:xfrm>
-          <a:prstGeom prst="rect">
-            <a:avLst/>
-          </a:prstGeom>
-          <a:noFill/>
-          <a:ln/>
-        </p:spPr>
-        <p:txBody>
-          <a:bodyPr wrap="square" lIns="0" tIns="0" rIns="0" bIns="0" rtlCol="0" anchor="t"/>
-          <a:lstStyle/>
-          <a:p>
-            <a:pPr indent="0" marL="0">
-              <a:lnSpc>
-                <a:spcPct val="92000"/>
-              </a:lnSpc>
-              <a:buNone/>
-            </a:pPr>
-            <a:r>
-              <a:rPr lang="en-US" sz="1150" dirty="0">
+          <p:cNvPr id="7" name="Text 4"/>
+          <p:cNvSpPr/>
+          <p:nvPr/>
+        </p:nvSpPr>
+        <p:spPr>
+          <a:xfrm>
+            <a:off x="749808" y="4059936"/>
+            <a:ext cx="7827264" cy="402336"/>
+          </a:xfrm>
+          <a:prstGeom prst="rect">
+            <a:avLst/>
+          </a:prstGeom>
+          <a:noFill/>
+          <a:ln/>
+        </p:spPr>
+        <p:txBody>
+          <a:bodyPr wrap="square" lIns="0" tIns="0" rIns="0" bIns="0" rtlCol="0" anchor="ctr"/>
+          <a:lstStyle/>
+          <a:p>
+            <a:pPr indent="0" marL="0">
+              <a:buNone/>
+            </a:pPr>
+            <a:r>
+              <a:rPr lang="en-US" sz="1200" b="1" dirty="0">
                 <a:solidFill>
                   <a:srgbClr val="434A63"/>
                 </a:solidFill>
@@ -10864,15 +10841,15 @@
                 <a:ea typeface="Arial" pitchFamily="34" charset="-122"/>
                 <a:cs typeface="Arial" pitchFamily="34" charset="-120"/>
               </a:rPr>
-              <a:t>Deshalb kann ein Router die IP lesen, ohne die Anwendung zu kennen: Er packt nur bis Schicht 3 aus, entscheidet, wohin es weitergeht, und verpackt wieder. Was darin steckt, geht ihn nichts an.</a:t>
-            </a:r>
-            <a:endParaRPr lang="en-US" sz="1150" dirty="0"/>
-          </a:p>
-        </p:txBody>
-      </p:sp>
-      <p:sp>
-        <p:nvSpPr>
-          <p:cNvPr id="9" name="Shape 6"/>
+              <a:t>Ein Router packt nur bis Schicht 3 aus – was in der HTTP-Nachricht steht, geht ihn nichts an.</a:t>
+            </a:r>
+            <a:endParaRPr lang="en-US" sz="1200" dirty="0"/>
+          </a:p>
+        </p:txBody>
+      </p:sp>
+      <p:sp>
+        <p:nvSpPr>
+          <p:cNvPr id="8" name="Shape 5"/>
           <p:cNvSpPr/>
           <p:nvPr/>
         </p:nvSpPr>
@@ -10895,7 +10872,7 @@
       </p:sp>
       <p:sp>
         <p:nvSpPr>
-          <p:cNvPr id="10" name="Text 7"/>
+          <p:cNvPr id="9" name="Text 6"/>
           <p:cNvSpPr/>
           <p:nvPr/>
         </p:nvSpPr>
@@ -10934,7 +10911,7 @@
       </p:sp>
       <p:sp>
         <p:nvSpPr>
-          <p:cNvPr id="11" name="Text 8"/>
+          <p:cNvPr id="10" name="Text 7"/>
           <p:cNvSpPr/>
           <p:nvPr/>
         </p:nvSpPr>

</xml_diff>

<commit_message>
folien: linux-befehle direkt an jeder stufe der diagnose-treppe
</commit_message>
<xml_diff>
--- a/folien/dist/01-netzwerke-grundlagen.pptx
+++ b/folien/dist/01-netzwerke-grundlagen.pptx
@@ -11094,8 +11094,8 @@
         </p:blipFill>
         <p:spPr>
           <a:xfrm>
-            <a:off x="566928" y="1517904"/>
-            <a:ext cx="8010144" cy="2331720"/>
+            <a:off x="566928" y="1481328"/>
+            <a:ext cx="8010144" cy="2468880"/>
           </a:xfrm>
           <a:prstGeom prst="rect">
             <a:avLst/>
@@ -11110,8 +11110,8 @@
         </p:nvSpPr>
         <p:spPr>
           <a:xfrm>
-            <a:off x="566928" y="3858768"/>
-            <a:ext cx="8010144" cy="548640"/>
+            <a:off x="566928" y="4023360"/>
+            <a:ext cx="8010144" cy="438912"/>
           </a:xfrm>
           <a:prstGeom prst="rect">
             <a:avLst/>
@@ -11130,8 +11130,8 @@
         </p:nvSpPr>
         <p:spPr>
           <a:xfrm>
-            <a:off x="566928" y="3858768"/>
-            <a:ext cx="41148" cy="548640"/>
+            <a:off x="566928" y="4023360"/>
+            <a:ext cx="41148" cy="438912"/>
           </a:xfrm>
           <a:prstGeom prst="rect">
             <a:avLst/>
@@ -11150,8 +11150,8 @@
         </p:nvSpPr>
         <p:spPr>
           <a:xfrm>
-            <a:off x="804672" y="4005072"/>
-            <a:ext cx="7607808" cy="283464"/>
+            <a:off x="804672" y="4169664"/>
+            <a:ext cx="7607808" cy="173736"/>
           </a:xfrm>
           <a:prstGeom prst="rect">
             <a:avLst/>
@@ -11167,9 +11167,6 @@
               <a:lnSpc>
                 <a:spcPct val="92000"/>
               </a:lnSpc>
-              <a:spcAft>
-                <a:spcPts val="500"/>
-              </a:spcAft>
               <a:buNone/>
             </a:pPr>
             <a:r>
@@ -11181,30 +11178,7 @@
                 <a:ea typeface="Arial" pitchFamily="34" charset="-122"/>
                 <a:cs typeface="Arial" pitchFamily="34" charset="-120"/>
               </a:rPr>
-              <a:t>macOS: ifconfig · arp -a · traceroute · dig</a:t>
-            </a:r>
-            <a:endParaRPr lang="en-US" sz="1050" dirty="0"/>
-          </a:p>
-          <a:p>
-            <a:pPr indent="0" marL="0">
-              <a:lnSpc>
-                <a:spcPct val="92000"/>
-              </a:lnSpc>
-              <a:spcAft>
-                <a:spcPts val="500"/>
-              </a:spcAft>
-              <a:buNone/>
-            </a:pPr>
-            <a:r>
-              <a:rPr lang="en-US" sz="1050" dirty="0">
-                <a:solidFill>
-                  <a:srgbClr val="434A63"/>
-                </a:solidFill>
-                <a:latin typeface="Arial" pitchFamily="34" charset="0"/>
-                <a:ea typeface="Arial" pitchFamily="34" charset="-122"/>
-                <a:cs typeface="Arial" pitchFamily="34" charset="-120"/>
-              </a:rPr>
-              <a:t>Linux: ip -brief addr · ip neigh · tracepath · resolvectl query</a:t>
+              <a:t>macOS: ifconfig · arp -a · traceroute · dig · nc -vz host port</a:t>
             </a:r>
             <a:endParaRPr lang="en-US" sz="1050" dirty="0"/>
           </a:p>

</xml_diff>